<commit_message>
feat(apresentacao): slide 'Por que agora' com dados de mercado + ajustes de pitch do vendedor
Novo slide 2 em todos os formatos: adoção de IA 88% (McKinsey State of AI
2025), US$ 252 bi investidos em 2024 (Stanford AI Index 2025) e retorno
médio de 3,7x por US$ 1 (IDC/Microsoft 2024) — números publicados, com
fonte citada no slide; contadores animados no HTML. Copy: 'gargalos que
consomem dinheiro ou limitam crescimento' no diagnóstico, 'software de
prateleira' na virada, 'tailor made' no Sistemas Sob Medida. Pitch HTML:
clique não navega mais (só setas/passador), hover nos marcos do gráfico/
pills/colunas/barras (tooltip com valor), curva do S7 até a margem,
descendentes dos títulos sem corte. Estáticos renumerados para 13 slides;
builder de imagens sem contagem hardcoded.

Co-Authored-By: Claude Fable 5 <noreply@anthropic.com>
</commit_message>
<xml_diff>
--- a/docs/apresentacao/Dreamy — Apresentação Institucional.pptx
+++ b/docs/apresentacao/Dreamy — Apresentação Institucional.pptx
@@ -17,6 +17,7 @@
     <p:sldId id="265" r:id="rId17"/>
     <p:sldId id="266" r:id="rId18"/>
     <p:sldId id="267" r:id="rId19"/>
+    <p:sldId id="268" r:id="rId20"/>
   </p:sldIdLst>
   <p:sldSz cx="12192000" cy="6858000" type="screen4x3"/>
   <p:notesSz cx="6858000" cy="9144000"/>
@@ -601,25 +602,37 @@
           <a:lstStyle/>
           <a:p>
             <a:r>
-              <a:t>Objetivo: reduzir o risco percebido — processo claro, ciclos curtos, sem sumiço. ≈ 45s</a:t>
+              <a:t>Objetivo: tornar concreto — três cenas do dia a dia que a plateia reconhece. ≈ 50s</a:t>
             </a:r>
           </a:p>
           <a:p/>
           <a:p>
             <a:r>
-              <a:t>E como é trabalhar com a gente? Cinco passos, sem mistério.</a:t>
+              <a:t>Três lugares onde isso fica concreto.</a:t>
             </a:r>
           </a:p>
           <a:p/>
           <a:p>
             <a:r>
-              <a:t>Entender: a gente senta junto e mapeia problema, impacto e contexto. Desenhar: solução, experiência, arquitetura. Construir: em ciclos curtos — você vê o software crescendo e valida no caminho; a gente não some seis meses para voltar com uma surpresa. Implantar: na operação real, com quem usa de verdade. E evoluir: porque software bom não termina — acompanha o negócio.</a:t>
+              <a:t>No atendimento: o agente responde, consulta as informações, registra tudo no CRM — e chama um humano quando a conversa pede um humano.</a:t>
             </a:r>
           </a:p>
           <a:p/>
           <a:p>
             <a:r>
-              <a:t>Em cada ciclo você sabe o que está sendo feito, por quê, e o que vem depois.</a:t>
+              <a:t>Em vendas: ele pesquisa o lead, qualifica, prepara o follow-up — o vendedor chega na conversa pronto, em vez de gastar a manhã pesquisando.</a:t>
+            </a:r>
+          </a:p>
+          <a:p/>
+          <a:p>
+            <a:r>
+              <a:t>Na operação: ele lê sistemas e documentos, consolida, analisa e age.</a:t>
+            </a:r>
+          </a:p>
+          <a:p/>
+          <a:p>
+            <a:r>
+              <a:t>Repara no padrão das três colunas: o agente fica com o trabalho repetitivo; as pessoas ficam com o que exige gente.</a:t>
             </a:r>
           </a:p>
         </p:txBody>
@@ -689,25 +702,25 @@
           <a:lstStyle/>
           <a:p>
             <a:r>
-              <a:t>Objetivo: qualificar com franqueza — quem tem fit se reconhece e se inclina. ≈ 40s</a:t>
+              <a:t>Objetivo: reduzir o risco percebido — processo claro, ciclos curtos, sem sumiço. ≈ 45s</a:t>
             </a:r>
           </a:p>
           <a:p/>
           <a:p>
             <a:r>
-              <a:t>Sendo bem direto sobre para quem isso funciona: o nosso trabalho rende mais em empresa que já funciona.</a:t>
+              <a:t>E como é trabalhar com a gente? Cinco passos, sem mistério.</a:t>
             </a:r>
           </a:p>
           <a:p/>
           <a:p>
             <a:r>
-              <a:t>Que já tem operação, clientes, time — e sente que a tecnologia virou o freio, e não o motor.</a:t>
+              <a:t>Entender: a gente senta junto e mapeia problema, impacto e contexto. Desenhar: solução, experiência, arquitetura. Construir: em ciclos curtos — você vê o software crescendo e valida no caminho; a gente não some seis meses para voltar com uma surpresa. Implantar: na operação real, com quem usa de verdade. E evoluir: porque software bom não termina — acompanha o negócio.</a:t>
             </a:r>
           </a:p>
           <a:p/>
           <a:p>
             <a:r>
-              <a:t>Se, enquanto eu falava, você lembrou de um processo que não escala, de sistemas que não conversam, de dados espalhados por aí... provavelmente existe algo que a gente pode construir juntos.</a:t>
+              <a:t>Em cada ciclo você sabe o que está sendo feito, por quê, e o que vem depois.</a:t>
             </a:r>
           </a:p>
         </p:txBody>
@@ -777,6 +790,94 @@
           <a:lstStyle/>
           <a:p>
             <a:r>
+              <a:t>Objetivo: qualificar com franqueza — quem tem fit se reconhece e se inclina. ≈ 40s</a:t>
+            </a:r>
+          </a:p>
+          <a:p/>
+          <a:p>
+            <a:r>
+              <a:t>Sendo bem direto sobre para quem isso funciona: o nosso trabalho rende mais em empresa que já funciona.</a:t>
+            </a:r>
+          </a:p>
+          <a:p/>
+          <a:p>
+            <a:r>
+              <a:t>Que já tem operação, clientes, time — e sente que a tecnologia virou o freio, e não o motor.</a:t>
+            </a:r>
+          </a:p>
+          <a:p/>
+          <a:p>
+            <a:r>
+              <a:t>Se, enquanto eu falava, você lembrou de um processo que não escala, de sistemas que não conversam, de dados espalhados por aí... provavelmente existe algo que a gente pode construir juntos.</a:t>
+            </a:r>
+          </a:p>
+        </p:txBody>
+      </p:sp>
+      <p:sp>
+        <p:nvSpPr>
+          <p:cNvPr id="4" name="Slide Number Placeholder 3"/>
+          <p:cNvSpPr>
+            <a:spLocks noGrp="1"/>
+          </p:cNvSpPr>
+          <p:nvPr>
+            <p:ph type="sldNum" idx="5" sz="quarter"/>
+          </p:nvPr>
+        </p:nvSpPr>
+        <p:spPr/>
+      </p:sp>
+    </p:spTree>
+  </p:cSld>
+  <p:clrMapOvr>
+    <a:masterClrMapping/>
+  </p:clrMapOvr>
+</p:notes>
+</file>
+
+<file path=ppt/notesSlides/notesSlide13.xml><?xml version="1.0" encoding="utf-8"?>
+<p:notes xmlns:a="http://schemas.openxmlformats.org/drawingml/2006/main" xmlns:p="http://schemas.openxmlformats.org/presentationml/2006/main" xmlns:r="http://schemas.openxmlformats.org/officeDocument/2006/relationships">
+  <p:cSld>
+    <p:spTree>
+      <p:nvGrpSpPr>
+        <p:cNvPr id="1" name=""/>
+        <p:cNvGrpSpPr/>
+        <p:nvPr/>
+      </p:nvGrpSpPr>
+      <p:grpSpPr>
+        <a:xfrm>
+          <a:off x="0" y="0"/>
+          <a:ext cx="0" cy="0"/>
+          <a:chOff x="0" y="0"/>
+          <a:chExt cx="0" cy="0"/>
+        </a:xfrm>
+      </p:grpSpPr>
+      <p:sp>
+        <p:nvSpPr>
+          <p:cNvPr id="2" name="Slide Image Placeholder 1"/>
+          <p:cNvSpPr>
+            <a:spLocks noGrp="1"/>
+          </p:cNvSpPr>
+          <p:nvPr>
+            <p:ph type="sldImg" idx="2"/>
+          </p:nvPr>
+        </p:nvSpPr>
+        <p:spPr/>
+      </p:sp>
+      <p:sp>
+        <p:nvSpPr>
+          <p:cNvPr id="3" name="Notes Placeholder 2"/>
+          <p:cNvSpPr>
+            <a:spLocks noGrp="1"/>
+          </p:cNvSpPr>
+          <p:nvPr>
+            <p:ph type="body" idx="3" sz="quarter"/>
+          </p:nvPr>
+        </p:nvSpPr>
+        <p:spPr/>
+        <p:txBody>
+          <a:bodyPr/>
+          <a:lstStyle/>
+          <a:p>
+            <a:r>
               <a:t>Objetivo: uma única pergunta + próximo passo simples. Termine e deixe a plateia falar. ≈ 40s</a:t>
             </a:r>
           </a:p>
@@ -883,31 +984,31 @@
           <a:lstStyle/>
           <a:p>
             <a:r>
-              <a:t>Objetivo: gerar identificação — a plateia precisa se reconhecer na cena. ≈ 60s</a:t>
+              <a:t>Urgência com dados de mercado — deixe os números falarem e não se alongue. ≈ 40s</a:t>
             </a:r>
           </a:p>
           <a:p/>
           <a:p>
             <a:r>
-              <a:t>Deixa eu descrever uma empresa, e você me diz se soa familiar.</a:t>
+              <a:t>Antes de falar da Dreamy, trinta segundos sobre o momento.</a:t>
             </a:r>
           </a:p>
           <a:p/>
           <a:p>
             <a:r>
-              <a:t>A empresa cresce. Os processos vão ficando cada vez mais específicos. Os sistemas param de conversar entre si. Alguma planilha — geralmente uma que só uma pessoa entende — passa a sustentar decisões importantes. E lá no comercial, leads esfriam sem ninguém perceber.</a:t>
+              <a:t>88% das empresas no mundo já usam IA em pelo menos uma função — eram 78% há um ano. Só em 2024, foram 252 bilhões de dólares investidos em IA. E quem investe está tendo retorno: em média, 3,7 dólares de volta para cada 1 investido.</a:t>
             </a:r>
           </a:p>
           <a:p/>
           <a:p>
             <a:r>
-              <a:t>[pausa — deixe a cena assentar]</a:t>
+              <a:t>[pausa curta]</a:t>
             </a:r>
           </a:p>
           <a:p/>
           <a:p>
             <a:r>
-              <a:t>Nada disso é falta de competência. É que a empresa cresceu mais rápido do que a tecnologia dela. E software pronto, de prateleira, não foi feito para o SEU processo — foi feito para a média.</a:t>
+              <a:t>Ou seja: a pergunta deixou de ser SE vale a pena. A pergunta agora é ONDE — no seu negócio. E é exatamente isso que a gente veio responder.</a:t>
             </a:r>
           </a:p>
         </p:txBody>
@@ -977,25 +1078,31 @@
           <a:lstStyle/>
           <a:p>
             <a:r>
-              <a:t>Objetivo: a virada. Slide quase vazio de propósito — a força está na pausa. ≈ 15s</a:t>
+              <a:t>Objetivo: gerar identificação — a plateia precisa se reconhecer na cena. ≈ 60s</a:t>
             </a:r>
           </a:p>
           <a:p/>
           <a:p>
             <a:r>
-              <a:t>E é exatamente nesse ponto que a gente entra.</a:t>
+              <a:t>Deixa eu descrever uma empresa, e você me diz se soa familiar.</a:t>
             </a:r>
           </a:p>
           <a:p/>
           <a:p>
             <a:r>
-              <a:t>[pausa longa — não corra este slide]</a:t>
+              <a:t>A empresa cresce. Os processos vão ficando cada vez mais específicos. Os sistemas param de conversar entre si. Alguma planilha — geralmente uma que só uma pessoa entende — passa a sustentar decisões importantes. E lá no comercial, leads esfriam sem ninguém perceber.</a:t>
             </a:r>
           </a:p>
           <a:p/>
           <a:p>
             <a:r>
-              <a:t>Quando o software pronto acaba e o seu problema continua — esse é o nosso território.</a:t>
+              <a:t>[pausa — deixe a cena assentar]</a:t>
+            </a:r>
+          </a:p>
+          <a:p/>
+          <a:p>
+            <a:r>
+              <a:t>Nada disso é falta de competência. É que a empresa cresceu mais rápido do que a tecnologia dela. E software pronto, de prateleira, não foi feito para o SEU processo — foi feito para a média.</a:t>
             </a:r>
           </a:p>
         </p:txBody>
@@ -1065,25 +1172,25 @@
           <a:lstStyle/>
           <a:p>
             <a:r>
-              <a:t>Objetivo: remover a maior objeção ('não sei o que pedir') e mostrar honestidade. ≈ 50s</a:t>
+              <a:t>Objetivo: a virada. Slide quase vazio de propósito — a força está na pausa. ≈ 15s</a:t>
             </a:r>
           </a:p>
           <a:p/>
           <a:p>
             <a:r>
-              <a:t>Uma coisa importante: você não precisa chegar para a gente sabendo o que construir.</a:t>
+              <a:t>E é exatamente nesse ponto que a gente entra.</a:t>
             </a:r>
           </a:p>
           <a:p/>
           <a:p>
             <a:r>
-              <a:t>Nenhum cliente nosso chegou com uma especificação técnica. Eles chegam com uma dor: "isso aqui demora demais", "estou desperdiçando oportunidade comercial", "não consigo enxergar a minha operação".</a:t>
+              <a:t>[pausa longa — não corra este slide]</a:t>
             </a:r>
           </a:p>
           <a:p/>
           <a:p>
             <a:r>
-              <a:t>O nosso trabalho começa aí — nessa régua do slide: entender a dor, medir o impacto, achar a oportunidade, desenhar a solução, e só então escolher a tecnologia. E às vezes a resposta honesta do diagnóstico é: não vale a pena construir nada. Essa honestidade faz parte do serviço — ninguém aqui quer vender software que não devolve resultado.</a:t>
+              <a:t>Quando o software pronto acaba e o seu problema continua — esse é o nosso território.</a:t>
             </a:r>
           </a:p>
         </p:txBody>
@@ -1153,25 +1260,25 @@
           <a:lstStyle/>
           <a:p>
             <a:r>
-              <a:t>Objetivo: dar o mapa da conversa e convidar a interrupção (engajamento). ≈ 40s</a:t>
+              <a:t>Objetivo: remover a maior objeção ('não sei o que pedir') e mostrar honestidade. ≈ 50s</a:t>
             </a:r>
           </a:p>
           <a:p/>
           <a:p>
             <a:r>
-              <a:t>Na prática, o que a gente constrói se organiza em três frentes.</a:t>
+              <a:t>Uma coisa importante: você não precisa chegar para a gente sabendo o que construir.</a:t>
             </a:r>
           </a:p>
           <a:p/>
           <a:p>
             <a:r>
-              <a:t>Um: receita nova — transformar o que a empresa já tem em um produto digital que os clientes dela pagariam para usar. Dois: operação — sistemas construídos em volta do seu processo, e não o contrário. Três: agentes de IA — colocar a IA para executar trabalho de verdade dentro da empresa.</a:t>
+              <a:t>Nenhum cliente nosso chegou com uma especificação técnica. Eles chegam com uma dor: "isso aqui demora demais", "estou desperdiçando oportunidade comercial", "não consigo enxergar a minha operação".</a:t>
             </a:r>
           </a:p>
           <a:p/>
           <a:p>
             <a:r>
-              <a:t>Vou passar rápido pelas três. E pode me interromper na hora em que alguma fizer clique com algo que vocês vivem aí dentro — essa é a parte boa da conversa.</a:t>
+              <a:t>O nosso trabalho começa aí — nessa régua do slide: entender a dor, medir o impacto, achar a oportunidade, desenhar a solução, e só então escolher a tecnologia. E às vezes a resposta honesta do diagnóstico é: não vale a pena construir nada. Essa honestidade faz parte do serviço — ninguém aqui quer vender software que não devolve resultado.</a:t>
             </a:r>
           </a:p>
         </p:txBody>
@@ -1241,31 +1348,25 @@
           <a:lstStyle/>
           <a:p>
             <a:r>
-              <a:t>Objetivo: plantar a pergunta que fica na cabeça depois da reunião. ≈ 60s</a:t>
+              <a:t>Objetivo: dar o mapa da conversa e convidar a interrupção (engajamento). ≈ 40s</a:t>
             </a:r>
           </a:p>
           <a:p/>
           <a:p>
             <a:r>
-              <a:t>Primeira frente.</a:t>
+              <a:t>Na prática, o que a gente constrói se organiza em três frentes.</a:t>
             </a:r>
           </a:p>
           <a:p/>
           <a:p>
             <a:r>
-              <a:t>A sua empresa já conquistou o mais difícil: clientes, confiança, conhecimento, distribuição. Isso levou anos. A pergunta que a gente faz é: o que MAIS essas pessoas comprariam de você?</a:t>
+              <a:t>Um: receita nova — transformar o que a empresa já tem em um produto digital que os clientes dela pagariam para usar. Dois: operação — sistemas construídos em volta do seu processo, e não o contrário. Três: agentes de IA — colocar a IA para executar trabalho de verdade dentro da empresa.</a:t>
             </a:r>
           </a:p>
           <a:p/>
           <a:p>
             <a:r>
-              <a:t>Pode ser um portal, uma assinatura, uma ferramenta que resolve uma dor do seu cliente. Cada produto nasce da base que já existe — por isso esse gráfico é conceitual, sem números: os números vêm do diagnóstico, do SEU caso, não de uma promessa genérica minha.</a:t>
-            </a:r>
-          </a:p>
-          <a:p/>
-          <a:p>
-            <a:r>
-              <a:t>Mas leva essa pergunta para casa: se uma parte dos seus clientes pagasse por um novo produto digital seu... o que valeria a pena construir?</a:t>
+              <a:t>Vou passar rápido pelas três. E pode me interromper na hora em que alguma fizer clique com algo que vocês vivem aí dentro — essa é a parte boa da conversa.</a:t>
             </a:r>
           </a:p>
         </p:txBody>
@@ -1335,31 +1436,31 @@
           <a:lstStyle/>
           <a:p>
             <a:r>
-              <a:t>Objetivo: inverter a lógica 'empresa se adapta ao software' e reforçar a parceria. ≈ 50s</a:t>
+              <a:t>Objetivo: plantar a pergunta que fica na cabeça depois da reunião. ≈ 60s</a:t>
             </a:r>
           </a:p>
           <a:p/>
           <a:p>
             <a:r>
-              <a:t>Segunda frente.</a:t>
+              <a:t>Primeira frente.</a:t>
             </a:r>
           </a:p>
           <a:p/>
           <a:p>
             <a:r>
-              <a:t>Hoje, a informação da sua operação mora em lugares demais — está aí no slide: planilha, ERP, e-mail, documento... e na cabeça de gente boa. Software genérico obriga a SUA empresa a se adaptar a ELE. A gente inverte isso: constrói o sistema em volta do seu processo.</a:t>
+              <a:t>A sua empresa já conquistou o mais difícil: clientes, confiança, conhecimento, distribuição. Isso levou anos. A pergunta que a gente faz é: o que MAIS essas pessoas comprariam de você?</a:t>
             </a:r>
           </a:p>
           <a:p/>
           <a:p>
             <a:r>
-              <a:t>O resultado é um lugar só, com a informação consolidada — e decisão com visibilidade, não no feeling.</a:t>
+              <a:t>Pode ser um portal, uma assinatura, uma ferramenta que resolve uma dor do seu cliente. Cada produto nasce da base que já existe — por isso esse gráfico é conceitual, sem números: os números vêm do diagnóstico, do SEU caso, não de uma promessa genérica minha.</a:t>
             </a:r>
           </a:p>
           <a:p/>
           <a:p>
             <a:r>
-              <a:t>E vale repetir: você não precisa trazer a solução pronta. Você conhece o seu negócio; nós conhecemos tecnologia. O desenho a gente faz junto.</a:t>
+              <a:t>Mas leva essa pergunta para casa: se uma parte dos seus clientes pagasse por um novo produto digital seu... o que valeria a pena construir?</a:t>
             </a:r>
           </a:p>
         </p:txBody>
@@ -1429,31 +1530,31 @@
           <a:lstStyle/>
           <a:p>
             <a:r>
-              <a:t>Objetivo: desfazer o mal-entendido 'agente = chatbot' e tranquilizar sobre controle. ≈ 50s</a:t>
+              <a:t>Objetivo: inverter a lógica 'empresa se adapta ao software' e reforçar a parceria. ≈ 50s</a:t>
             </a:r>
           </a:p>
           <a:p/>
           <a:p>
             <a:r>
-              <a:t>Terceira frente — e aqui eu preciso desfazer um mal-entendido.</a:t>
+              <a:t>Segunda frente.</a:t>
             </a:r>
           </a:p>
           <a:p/>
           <a:p>
             <a:r>
-              <a:t>Agente de IA não é chatbot. É software que executa etapas de um processo: interpreta informação, acessa as ferramentas que VOCÊ autorizar — CRM, ERP, WhatsApp, e-mail, documentos — e faz o trabalho.</a:t>
+              <a:t>Hoje, a informação da sua operação mora em lugares demais — está aí no slide: planilha, ERP, e-mail, documento... e na cabeça de gente boa. Software genérico obriga a SUA empresa a se adaptar a ELE. A gente inverte isso: constrói o sistema em volta do seu processo.</a:t>
             </a:r>
           </a:p>
           <a:p/>
           <a:p>
             <a:r>
-              <a:t>Com escopo definido, com regras, com permissões. E quando o assunto precisa de gente, ele passa para gente — está aí na saída de baixo do diagrama.</a:t>
+              <a:t>O resultado é um lugar só, com a informação consolidada — e decisão com visibilidade, não no feeling.</a:t>
             </a:r>
           </a:p>
           <a:p/>
           <a:p>
             <a:r>
-              <a:t>Autonomia com controle. Sempre nessa ordem.</a:t>
+              <a:t>E vale repetir: você não precisa trazer a solução pronta. Você conhece o seu negócio; nós conhecemos tecnologia. O desenho a gente faz junto.</a:t>
             </a:r>
           </a:p>
         </p:txBody>
@@ -1523,37 +1624,31 @@
           <a:lstStyle/>
           <a:p>
             <a:r>
-              <a:t>Objetivo: tornar concreto — três cenas do dia a dia que a plateia reconhece. ≈ 50s</a:t>
+              <a:t>Objetivo: desfazer o mal-entendido 'agente = chatbot' e tranquilizar sobre controle. ≈ 50s</a:t>
             </a:r>
           </a:p>
           <a:p/>
           <a:p>
             <a:r>
-              <a:t>Três lugares onde isso fica concreto.</a:t>
+              <a:t>Terceira frente — e aqui eu preciso desfazer um mal-entendido.</a:t>
             </a:r>
           </a:p>
           <a:p/>
           <a:p>
             <a:r>
-              <a:t>No atendimento: o agente responde, consulta as informações, registra tudo no CRM — e chama um humano quando a conversa pede um humano.</a:t>
+              <a:t>Agente de IA não é chatbot. É software que executa etapas de um processo: interpreta informação, acessa as ferramentas que VOCÊ autorizar — CRM, ERP, WhatsApp, e-mail, documentos — e faz o trabalho.</a:t>
             </a:r>
           </a:p>
           <a:p/>
           <a:p>
             <a:r>
-              <a:t>Em vendas: ele pesquisa o lead, qualifica, prepara o follow-up — o vendedor chega na conversa pronto, em vez de gastar a manhã pesquisando.</a:t>
+              <a:t>Com escopo definido, com regras, com permissões. E quando o assunto precisa de gente, ele passa para gente — está aí na saída de baixo do diagrama.</a:t>
             </a:r>
           </a:p>
           <a:p/>
           <a:p>
             <a:r>
-              <a:t>Na operação: ele lê sistemas e documentos, consolida, analisa e age.</a:t>
-            </a:r>
-          </a:p>
-          <a:p/>
-          <a:p>
-            <a:r>
-              <a:t>Repara no padrão das três colunas: o agente fica com o trabalho repetitivo; as pessoas ficam com o que exige gente.</a:t>
+              <a:t>Autonomia com controle. Sempre nessa ordem.</a:t>
             </a:r>
           </a:p>
         </p:txBody>
@@ -4688,6 +4783,48 @@
       <p:pic>
         <p:nvPicPr>
           <p:cNvPr id="2" name="Picture 1" descr="slide-12.png"/>
+          <p:cNvPicPr>
+            <a:picLocks noChangeAspect="1"/>
+          </p:cNvPicPr>
+          <p:nvPr/>
+        </p:nvPicPr>
+        <p:blipFill>
+          <a:blip r:embed="rId2"/>
+          <a:stretch>
+            <a:fillRect/>
+          </a:stretch>
+        </p:blipFill>
+        <p:spPr>
+          <a:xfrm>
+            <a:off x="0" y="0"/>
+            <a:ext cx="12192000" cy="6858000"/>
+          </a:xfrm>
+          <a:prstGeom prst="rect">
+            <a:avLst/>
+          </a:prstGeom>
+        </p:spPr>
+      </p:pic>
+    </p:spTree>
+  </p:cSld>
+  <p:clrMapOvr>
+    <a:masterClrMapping/>
+  </p:clrMapOvr>
+</p:sld>
+</file>
+
+<file path=ppt/slides/slide13.xml><?xml version="1.0" encoding="utf-8"?>
+<p:sld xmlns:a="http://schemas.openxmlformats.org/drawingml/2006/main" xmlns:p="http://schemas.openxmlformats.org/presentationml/2006/main" xmlns:r="http://schemas.openxmlformats.org/officeDocument/2006/relationships">
+  <p:cSld>
+    <p:spTree>
+      <p:nvGrpSpPr>
+        <p:cNvPr id="1" name=""/>
+        <p:cNvGrpSpPr/>
+        <p:nvPr/>
+      </p:nvGrpSpPr>
+      <p:grpSpPr/>
+      <p:pic>
+        <p:nvPicPr>
+          <p:cNvPr id="2" name="Picture 1" descr="slide-13.png"/>
           <p:cNvPicPr>
             <a:picLocks noChangeAspect="1"/>
           </p:cNvPicPr>

</xml_diff>

<commit_message>
feat(apresentacao): versão de leitura — simulação com exemplo padrão nos formatos estáticos
Para envio do PDF a contatos (leitura sem apresentador): novo slide 8 em
PDF/PPTXs com a simulação calculada num exemplo ilustrativo (500 clientes
× R$ 149 × 30% de adesão → MRR R$ 22.350, + R$ 268.200/ano, rampa de 12
meses e custo de espera), rotulado 'Exemplo ilustrativo' com convite para
simular com números reais no diagnóstico. Fechamento ganha a linha de
contexto do PRD para o leitor frio. Paridade: 4 formatos com 14 slides
(HTML mantém o simulador interativo). Estáticos renumerados; roteiro com
a nota do slide novo.

Co-Authored-By: Claude Fable 5 <noreply@anthropic.com>
</commit_message>
<xml_diff>
--- a/docs/apresentacao/Dreamy — Apresentação Institucional.pptx
+++ b/docs/apresentacao/Dreamy — Apresentação Institucional.pptx
@@ -18,6 +18,7 @@
     <p:sldId id="266" r:id="rId18"/>
     <p:sldId id="267" r:id="rId19"/>
     <p:sldId id="268" r:id="rId20"/>
+    <p:sldId id="269" r:id="rId21"/>
   </p:sldIdLst>
   <p:sldSz cx="12192000" cy="6858000" type="screen4x3"/>
   <p:notesSz cx="6858000" cy="9144000"/>
@@ -602,37 +603,31 @@
           <a:lstStyle/>
           <a:p>
             <a:r>
-              <a:t>Objetivo: tornar concreto — três cenas do dia a dia que a plateia reconhece. ≈ 50s</a:t>
+              <a:t>Objetivo: desfazer o mal-entendido 'agente = chatbot' e tranquilizar sobre controle. ≈ 50s</a:t>
             </a:r>
           </a:p>
           <a:p/>
           <a:p>
             <a:r>
-              <a:t>Três lugares onde isso fica concreto.</a:t>
+              <a:t>Terceira frente — e aqui eu preciso desfazer um mal-entendido.</a:t>
             </a:r>
           </a:p>
           <a:p/>
           <a:p>
             <a:r>
-              <a:t>No atendimento: o agente responde, consulta as informações, registra tudo no CRM — e chama um humano quando a conversa pede um humano.</a:t>
+              <a:t>Agente de IA não é chatbot. É software que executa etapas de um processo: interpreta informação, acessa as ferramentas que VOCÊ autorizar — CRM, ERP, WhatsApp, e-mail, documentos — e faz o trabalho.</a:t>
             </a:r>
           </a:p>
           <a:p/>
           <a:p>
             <a:r>
-              <a:t>Em vendas: ele pesquisa o lead, qualifica, prepara o follow-up — o vendedor chega na conversa pronto, em vez de gastar a manhã pesquisando.</a:t>
+              <a:t>Com escopo definido, com regras, com permissões. E quando o assunto precisa de gente, ele passa para gente — está aí na saída de baixo do diagrama.</a:t>
             </a:r>
           </a:p>
           <a:p/>
           <a:p>
             <a:r>
-              <a:t>Na operação: ele lê sistemas e documentos, consolida, analisa e age.</a:t>
-            </a:r>
-          </a:p>
-          <a:p/>
-          <a:p>
-            <a:r>
-              <a:t>Repara no padrão das três colunas: o agente fica com o trabalho repetitivo; as pessoas ficam com o que exige gente.</a:t>
+              <a:t>Autonomia com controle. Sempre nessa ordem.</a:t>
             </a:r>
           </a:p>
         </p:txBody>
@@ -702,25 +697,37 @@
           <a:lstStyle/>
           <a:p>
             <a:r>
-              <a:t>Objetivo: reduzir o risco percebido — processo claro, ciclos curtos, sem sumiço. ≈ 45s</a:t>
+              <a:t>Objetivo: tornar concreto — três cenas do dia a dia que a plateia reconhece. ≈ 50s</a:t>
             </a:r>
           </a:p>
           <a:p/>
           <a:p>
             <a:r>
-              <a:t>E como é trabalhar com a gente? Cinco passos, sem mistério.</a:t>
+              <a:t>Três lugares onde isso fica concreto.</a:t>
             </a:r>
           </a:p>
           <a:p/>
           <a:p>
             <a:r>
-              <a:t>Entender: a gente senta junto e mapeia problema, impacto e contexto. Desenhar: solução, experiência, arquitetura. Construir: em ciclos curtos — você vê o software crescendo e valida no caminho; a gente não some seis meses para voltar com uma surpresa. Implantar: na operação real, com quem usa de verdade. E evoluir: porque software bom não termina — acompanha o negócio.</a:t>
+              <a:t>No atendimento: o agente responde, consulta as informações, registra tudo no CRM — e chama um humano quando a conversa pede um humano.</a:t>
             </a:r>
           </a:p>
           <a:p/>
           <a:p>
             <a:r>
-              <a:t>Em cada ciclo você sabe o que está sendo feito, por quê, e o que vem depois.</a:t>
+              <a:t>Em vendas: ele pesquisa o lead, qualifica, prepara o follow-up — o vendedor chega na conversa pronto, em vez de gastar a manhã pesquisando.</a:t>
+            </a:r>
+          </a:p>
+          <a:p/>
+          <a:p>
+            <a:r>
+              <a:t>Na operação: ele lê sistemas e documentos, consolida, analisa e age.</a:t>
+            </a:r>
+          </a:p>
+          <a:p/>
+          <a:p>
+            <a:r>
+              <a:t>Repara no padrão das três colunas: o agente fica com o trabalho repetitivo; as pessoas ficam com o que exige gente.</a:t>
             </a:r>
           </a:p>
         </p:txBody>
@@ -790,25 +797,25 @@
           <a:lstStyle/>
           <a:p>
             <a:r>
-              <a:t>Objetivo: qualificar com franqueza — quem tem fit se reconhece e se inclina. ≈ 40s</a:t>
+              <a:t>Objetivo: reduzir o risco percebido — processo claro, ciclos curtos, sem sumiço. ≈ 45s</a:t>
             </a:r>
           </a:p>
           <a:p/>
           <a:p>
             <a:r>
-              <a:t>Sendo bem direto sobre para quem isso funciona: o nosso trabalho rende mais em empresa que já funciona.</a:t>
+              <a:t>E como é trabalhar com a gente? Cinco passos, sem mistério.</a:t>
             </a:r>
           </a:p>
           <a:p/>
           <a:p>
             <a:r>
-              <a:t>Que já tem operação, clientes, time — e sente que a tecnologia virou o freio, e não o motor.</a:t>
+              <a:t>Entender: a gente senta junto e mapeia problema, impacto e contexto. Desenhar: solução, experiência, arquitetura. Construir: em ciclos curtos — você vê o software crescendo e valida no caminho; a gente não some seis meses para voltar com uma surpresa. Implantar: na operação real, com quem usa de verdade. E evoluir: porque software bom não termina — acompanha o negócio.</a:t>
             </a:r>
           </a:p>
           <a:p/>
           <a:p>
             <a:r>
-              <a:t>Se, enquanto eu falava, você lembrou de um processo que não escala, de sistemas que não conversam, de dados espalhados por aí... provavelmente existe algo que a gente pode construir juntos.</a:t>
+              <a:t>Em cada ciclo você sabe o que está sendo feito, por quê, e o que vem depois.</a:t>
             </a:r>
           </a:p>
         </p:txBody>
@@ -878,6 +885,94 @@
           <a:lstStyle/>
           <a:p>
             <a:r>
+              <a:t>Objetivo: qualificar com franqueza — quem tem fit se reconhece e se inclina. ≈ 40s</a:t>
+            </a:r>
+          </a:p>
+          <a:p/>
+          <a:p>
+            <a:r>
+              <a:t>Sendo bem direto sobre para quem isso funciona: o nosso trabalho rende mais em empresa que já funciona.</a:t>
+            </a:r>
+          </a:p>
+          <a:p/>
+          <a:p>
+            <a:r>
+              <a:t>Que já tem operação, clientes, time — e sente que a tecnologia virou o freio, e não o motor.</a:t>
+            </a:r>
+          </a:p>
+          <a:p/>
+          <a:p>
+            <a:r>
+              <a:t>Se, enquanto eu falava, você lembrou de um processo que não escala, de sistemas que não conversam, de dados espalhados por aí... provavelmente existe algo que a gente pode construir juntos.</a:t>
+            </a:r>
+          </a:p>
+        </p:txBody>
+      </p:sp>
+      <p:sp>
+        <p:nvSpPr>
+          <p:cNvPr id="4" name="Slide Number Placeholder 3"/>
+          <p:cNvSpPr>
+            <a:spLocks noGrp="1"/>
+          </p:cNvSpPr>
+          <p:nvPr>
+            <p:ph type="sldNum" idx="5" sz="quarter"/>
+          </p:nvPr>
+        </p:nvSpPr>
+        <p:spPr/>
+      </p:sp>
+    </p:spTree>
+  </p:cSld>
+  <p:clrMapOvr>
+    <a:masterClrMapping/>
+  </p:clrMapOvr>
+</p:notes>
+</file>
+
+<file path=ppt/notesSlides/notesSlide14.xml><?xml version="1.0" encoding="utf-8"?>
+<p:notes xmlns:a="http://schemas.openxmlformats.org/drawingml/2006/main" xmlns:p="http://schemas.openxmlformats.org/presentationml/2006/main" xmlns:r="http://schemas.openxmlformats.org/officeDocument/2006/relationships">
+  <p:cSld>
+    <p:spTree>
+      <p:nvGrpSpPr>
+        <p:cNvPr id="1" name=""/>
+        <p:cNvGrpSpPr/>
+        <p:nvPr/>
+      </p:nvGrpSpPr>
+      <p:grpSpPr>
+        <a:xfrm>
+          <a:off x="0" y="0"/>
+          <a:ext cx="0" cy="0"/>
+          <a:chOff x="0" y="0"/>
+          <a:chExt cx="0" cy="0"/>
+        </a:xfrm>
+      </p:grpSpPr>
+      <p:sp>
+        <p:nvSpPr>
+          <p:cNvPr id="2" name="Slide Image Placeholder 1"/>
+          <p:cNvSpPr>
+            <a:spLocks noGrp="1"/>
+          </p:cNvSpPr>
+          <p:nvPr>
+            <p:ph type="sldImg" idx="2"/>
+          </p:nvPr>
+        </p:nvSpPr>
+        <p:spPr/>
+      </p:sp>
+      <p:sp>
+        <p:nvSpPr>
+          <p:cNvPr id="3" name="Notes Placeholder 2"/>
+          <p:cNvSpPr>
+            <a:spLocks noGrp="1"/>
+          </p:cNvSpPr>
+          <p:nvPr>
+            <p:ph type="body" idx="3" sz="quarter"/>
+          </p:nvPr>
+        </p:nvSpPr>
+        <p:spPr/>
+        <p:txBody>
+          <a:bodyPr/>
+          <a:lstStyle/>
+          <a:p>
+            <a:r>
               <a:t>Objetivo: uma única pergunta + próximo passo simples. Termine e deixe a plateia falar. ≈ 40s</a:t>
             </a:r>
           </a:p>
@@ -1530,31 +1625,25 @@
           <a:lstStyle/>
           <a:p>
             <a:r>
-              <a:t>Objetivo: inverter a lógica 'empresa se adapta ao software' e reforçar a parceria. ≈ 50s</a:t>
+              <a:t>No material enviado, este slide se explica sozinho. Ao vivo, prefira o simulador interativo do pitch HTML. ≈ 30s</a:t>
             </a:r>
           </a:p>
           <a:p/>
           <a:p>
             <a:r>
-              <a:t>Segunda frente.</a:t>
+              <a:t>Um exemplo com números redondos: uma empresa com 500 clientes ativos, um produto digital de R$ 149 por mês, e um cenário conservador — só 30% da base aderindo.</a:t>
             </a:r>
           </a:p>
           <a:p/>
           <a:p>
             <a:r>
-              <a:t>Hoje, a informação da sua operação mora em lugares demais — está aí no slide: planilha, ERP, e-mail, documento... e na cabeça de gente boa. Software genérico obriga a SUA empresa a se adaptar a ELE. A gente inverte isso: constrói o sistema em volta do seu processo.</a:t>
+              <a:t>Isso já significa R$ 22.350 novos por mês — R$ 268.200 por ano. E cada mês sem o produto no ar é esse valor que fica na mesa.</a:t>
             </a:r>
           </a:p>
           <a:p/>
           <a:p>
             <a:r>
-              <a:t>O resultado é um lugar só, com a informação consolidada — e decisão com visibilidade, não no feeling.</a:t>
-            </a:r>
-          </a:p>
-          <a:p/>
-          <a:p>
-            <a:r>
-              <a:t>E vale repetir: você não precisa trazer a solução pronta. Você conhece o seu negócio; nós conhecemos tecnologia. O desenho a gente faz junto.</a:t>
+              <a:t>No diagnóstico, a simulação é refeita com os números reais da empresa.</a:t>
             </a:r>
           </a:p>
         </p:txBody>
@@ -1624,31 +1713,31 @@
           <a:lstStyle/>
           <a:p>
             <a:r>
-              <a:t>Objetivo: desfazer o mal-entendido 'agente = chatbot' e tranquilizar sobre controle. ≈ 50s</a:t>
+              <a:t>Objetivo: inverter a lógica 'empresa se adapta ao software' e reforçar a parceria. ≈ 50s</a:t>
             </a:r>
           </a:p>
           <a:p/>
           <a:p>
             <a:r>
-              <a:t>Terceira frente — e aqui eu preciso desfazer um mal-entendido.</a:t>
+              <a:t>Segunda frente.</a:t>
             </a:r>
           </a:p>
           <a:p/>
           <a:p>
             <a:r>
-              <a:t>Agente de IA não é chatbot. É software que executa etapas de um processo: interpreta informação, acessa as ferramentas que VOCÊ autorizar — CRM, ERP, WhatsApp, e-mail, documentos — e faz o trabalho.</a:t>
+              <a:t>Hoje, a informação da sua operação mora em lugares demais — está aí no slide: planilha, ERP, e-mail, documento... e na cabeça de gente boa. Software genérico obriga a SUA empresa a se adaptar a ELE. A gente inverte isso: constrói o sistema em volta do seu processo.</a:t>
             </a:r>
           </a:p>
           <a:p/>
           <a:p>
             <a:r>
-              <a:t>Com escopo definido, com regras, com permissões. E quando o assunto precisa de gente, ele passa para gente — está aí na saída de baixo do diagrama.</a:t>
+              <a:t>O resultado é um lugar só, com a informação consolidada — e decisão com visibilidade, não no feeling.</a:t>
             </a:r>
           </a:p>
           <a:p/>
           <a:p>
             <a:r>
-              <a:t>Autonomia com controle. Sempre nessa ordem.</a:t>
+              <a:t>E vale repetir: você não precisa trazer a solução pronta. Você conhece o seu negócio; nós conhecemos tecnologia. O desenho a gente faz junto.</a:t>
             </a:r>
           </a:p>
         </p:txBody>
@@ -4825,6 +4914,48 @@
       <p:pic>
         <p:nvPicPr>
           <p:cNvPr id="2" name="Picture 1" descr="slide-13.png"/>
+          <p:cNvPicPr>
+            <a:picLocks noChangeAspect="1"/>
+          </p:cNvPicPr>
+          <p:nvPr/>
+        </p:nvPicPr>
+        <p:blipFill>
+          <a:blip r:embed="rId2"/>
+          <a:stretch>
+            <a:fillRect/>
+          </a:stretch>
+        </p:blipFill>
+        <p:spPr>
+          <a:xfrm>
+            <a:off x="0" y="0"/>
+            <a:ext cx="12192000" cy="6858000"/>
+          </a:xfrm>
+          <a:prstGeom prst="rect">
+            <a:avLst/>
+          </a:prstGeom>
+        </p:spPr>
+      </p:pic>
+    </p:spTree>
+  </p:cSld>
+  <p:clrMapOvr>
+    <a:masterClrMapping/>
+  </p:clrMapOvr>
+</p:sld>
+</file>
+
+<file path=ppt/slides/slide14.xml><?xml version="1.0" encoding="utf-8"?>
+<p:sld xmlns:a="http://schemas.openxmlformats.org/drawingml/2006/main" xmlns:p="http://schemas.openxmlformats.org/presentationml/2006/main" xmlns:r="http://schemas.openxmlformats.org/officeDocument/2006/relationships">
+  <p:cSld>
+    <p:spTree>
+      <p:nvGrpSpPr>
+        <p:cNvPr id="1" name=""/>
+        <p:cNvGrpSpPr/>
+        <p:nvPr/>
+      </p:nvGrpSpPr>
+      <p:grpSpPr/>
+      <p:pic>
+        <p:nvPicPr>
+          <p:cNvPr id="2" name="Picture 1" descr="slide-14.png"/>
           <p:cNvPicPr>
             <a:picLocks noChangeAspect="1"/>
           </p:cNvPicPr>

</xml_diff>